<commit_message>
TDL 簡報加入 Q8b:benchmark 題型與範例(MCQ vs 數值題/MRA;VLM4D 原 teaser)
Co-Authored-By: Claude Fable 5 <noreply@anthropic.com>
</commit_message>
<xml_diff>
--- a/slides/TDL_7頁回答.pptx
+++ b/slides/TDL_7頁回答.pptx
@@ -14,6 +14,7 @@
     <p:sldId id="262" r:id="rId14"/>
     <p:sldId id="263" r:id="rId15"/>
     <p:sldId id="264" r:id="rId16"/>
+    <p:sldId id="265" r:id="rId17"/>
   </p:sldIdLst>
   <p:sldSz cx="12191695" cy="6858000" type="screen4x3"/>
   <p:notesSz cx="6858000" cy="9144000"/>
@@ -535,6 +536,76 @@
 </p:notes>
 </file>
 
+<file path=ppt/notesSlides/notesSlide10.xml><?xml version="1.0" encoding="utf-8"?>
+<p:notes xmlns:a="http://schemas.openxmlformats.org/drawingml/2006/main" xmlns:p="http://schemas.openxmlformats.org/presentationml/2006/main" xmlns:r="http://schemas.openxmlformats.org/officeDocument/2006/relationships">
+  <p:cSld>
+    <p:spTree>
+      <p:nvGrpSpPr>
+        <p:cNvPr id="1" name=""/>
+        <p:cNvGrpSpPr/>
+        <p:nvPr/>
+      </p:nvGrpSpPr>
+      <p:grpSpPr>
+        <a:xfrm>
+          <a:off x="0" y="0"/>
+          <a:ext cx="0" cy="0"/>
+          <a:chOff x="0" y="0"/>
+          <a:chExt cx="0" cy="0"/>
+        </a:xfrm>
+      </p:grpSpPr>
+      <p:sp>
+        <p:nvSpPr>
+          <p:cNvPr id="2" name="Slide Image Placeholder 1"/>
+          <p:cNvSpPr>
+            <a:spLocks noGrp="1"/>
+          </p:cNvSpPr>
+          <p:nvPr>
+            <p:ph type="sldImg" idx="2"/>
+          </p:nvPr>
+        </p:nvSpPr>
+        <p:spPr/>
+      </p:sp>
+      <p:sp>
+        <p:nvSpPr>
+          <p:cNvPr id="3" name="Notes Placeholder 2"/>
+          <p:cNvSpPr>
+            <a:spLocks noGrp="1"/>
+          </p:cNvSpPr>
+          <p:nvPr>
+            <p:ph type="body" idx="3" sz="quarter"/>
+          </p:nvPr>
+        </p:nvSpPr>
+        <p:spPr/>
+        <p:txBody>
+          <a:bodyPr/>
+          <a:lstStyle/>
+          <a:p>
+            <a:r>
+              <a:t>收尾頁。這 6 題對應 notes/理解整理_7題.md 的「只有你能回答」欄。</a:t>
+            </a:r>
+          </a:p>
+        </p:txBody>
+      </p:sp>
+      <p:sp>
+        <p:nvSpPr>
+          <p:cNvPr id="4" name="Slide Number Placeholder 3"/>
+          <p:cNvSpPr>
+            <a:spLocks noGrp="1"/>
+          </p:cNvSpPr>
+          <p:nvPr>
+            <p:ph type="sldNum" idx="5" sz="quarter"/>
+          </p:nvPr>
+        </p:nvSpPr>
+        <p:spPr/>
+      </p:sp>
+    </p:spTree>
+  </p:cSld>
+  <p:clrMapOvr>
+    <a:masterClrMapping/>
+  </p:clrMapOvr>
+</p:notes>
+</file>
+
 <file path=ppt/notesSlides/notesSlide2.xml><?xml version="1.0" encoding="utf-8"?>
 <p:notes xmlns:a="http://schemas.openxmlformats.org/drawingml/2006/main" xmlns:p="http://schemas.openxmlformats.org/presentationml/2006/main" xmlns:r="http://schemas.openxmlformats.org/officeDocument/2006/relationships">
   <p:cSld>
@@ -1070,7 +1141,7 @@
           <a:lstStyle/>
           <a:p>
             <a:r>
-              <a:t>收尾頁。這 6 題對應 notes/理解整理_7題.md 的「只有你能回答」欄。</a:t>
+              <a:t>Q8 補充頁。重點:(1) MCQ vs 數值題兩種格式,數值題用相對準確率;(2) STI 的定量選項設計逼出度量能力;(3) 圖是 VLM4D 原 teaser,直接演示失敗案例。示意題需換原題。</a:t>
             </a:r>
           </a:p>
         </p:txBody>
@@ -4627,7 +4698,511 @@
                 </a:solidFill>
                 <a:latin typeface="Segoe UI"/>
               </a:rPr>
-              <a:t>1/9 · 草稿</a:t>
+              <a:t>1/10 · 草稿</a:t>
+            </a:r>
+          </a:p>
+        </p:txBody>
+      </p:sp>
+    </p:spTree>
+  </p:cSld>
+  <p:clrMapOvr>
+    <a:masterClrMapping/>
+  </p:clrMapOvr>
+</p:sld>
+</file>
+
+<file path=ppt/slides/slide10.xml><?xml version="1.0" encoding="utf-8"?>
+<p:sld xmlns:a="http://schemas.openxmlformats.org/drawingml/2006/main" xmlns:p="http://schemas.openxmlformats.org/presentationml/2006/main" xmlns:r="http://schemas.openxmlformats.org/officeDocument/2006/relationships">
+  <p:cSld>
+    <p:spTree>
+      <p:nvGrpSpPr>
+        <p:cNvPr id="1" name=""/>
+        <p:cNvGrpSpPr/>
+        <p:nvPr/>
+      </p:nvGrpSpPr>
+      <p:grpSpPr/>
+      <p:sp>
+        <p:nvSpPr>
+          <p:cNvPr id="2" name="Rectangle 1"/>
+          <p:cNvSpPr/>
+          <p:nvPr/>
+        </p:nvSpPr>
+        <p:spPr>
+          <a:xfrm>
+            <a:off x="0" y="0"/>
+            <a:ext cx="12191695" cy="6858000"/>
+          </a:xfrm>
+          <a:prstGeom prst="rect">
+            <a:avLst/>
+          </a:prstGeom>
+          <a:solidFill>
+            <a:srgbClr val="FFFFFF"/>
+          </a:solidFill>
+          <a:ln>
+            <a:noFill/>
+          </a:ln>
+          <a:effectLst/>
+        </p:spPr>
+        <p:style>
+          <a:lnRef idx="1">
+            <a:schemeClr val="accent1"/>
+          </a:lnRef>
+          <a:fillRef idx="3">
+            <a:schemeClr val="accent1"/>
+          </a:fillRef>
+          <a:effectRef idx="2">
+            <a:schemeClr val="accent1"/>
+          </a:effectRef>
+          <a:fontRef idx="minor">
+            <a:schemeClr val="lt1"/>
+          </a:fontRef>
+        </p:style>
+        <p:txBody>
+          <a:bodyPr rtlCol="0" anchor="ctr"/>
+          <a:lstStyle/>
+          <a:p>
+            <a:pPr algn="ctr"/>
+          </a:p>
+        </p:txBody>
+      </p:sp>
+      <p:sp>
+        <p:nvSpPr>
+          <p:cNvPr id="3" name="TextBox 2"/>
+          <p:cNvSpPr txBox="1"/>
+          <p:nvPr/>
+        </p:nvSpPr>
+        <p:spPr>
+          <a:xfrm>
+            <a:off x="640080" y="384048"/>
+            <a:ext cx="10881360" cy="365760"/>
+          </a:xfrm>
+          <a:prstGeom prst="rect">
+            <a:avLst/>
+          </a:prstGeom>
+          <a:noFill/>
+        </p:spPr>
+        <p:txBody>
+          <a:bodyPr wrap="square" anchor="t" lIns="0" rIns="0" tIns="0" bIns="0">
+            <a:spAutoFit/>
+          </a:bodyPr>
+          <a:lstStyle/>
+          <a:p>
+            <a:pPr algn="l">
+              <a:lnSpc>
+                <a:spcPct val="110000"/>
+              </a:lnSpc>
+              <a:spcBef>
+                <a:spcPts val="0"/>
+              </a:spcBef>
+              <a:spcAft>
+                <a:spcPts val="500"/>
+              </a:spcAft>
+            </a:pPr>
+            <a:r>
+              <a:rPr sz="1500" b="1" i="0">
+                <a:solidFill>
+                  <a:srgbClr val="0F768E"/>
+                </a:solidFill>
+                <a:latin typeface="Segoe UI"/>
+              </a:rPr>
+              <a:t>Q9　</a:t>
+            </a:r>
+            <a:r>
+              <a:rPr sz="1250" b="0" i="0">
+                <a:solidFill>
+                  <a:srgbClr val="555B63"/>
+                </a:solidFill>
+                <a:latin typeface="Microsoft JhengHei"/>
+              </a:rPr>
+              <a:t>skill 憲法第 4 條:這些問題 Claude 回答不了,由你回答。</a:t>
+            </a:r>
+          </a:p>
+        </p:txBody>
+      </p:sp>
+      <p:sp>
+        <p:nvSpPr>
+          <p:cNvPr id="4" name="Rectangle 3"/>
+          <p:cNvSpPr/>
+          <p:nvPr/>
+        </p:nvSpPr>
+        <p:spPr>
+          <a:xfrm>
+            <a:off x="640080" y="804672"/>
+            <a:ext cx="10881360" cy="14630"/>
+          </a:xfrm>
+          <a:prstGeom prst="rect">
+            <a:avLst/>
+          </a:prstGeom>
+          <a:solidFill>
+            <a:srgbClr val="DDDDDD"/>
+          </a:solidFill>
+          <a:ln>
+            <a:noFill/>
+          </a:ln>
+          <a:effectLst/>
+        </p:spPr>
+        <p:style>
+          <a:lnRef idx="1">
+            <a:schemeClr val="accent1"/>
+          </a:lnRef>
+          <a:fillRef idx="3">
+            <a:schemeClr val="accent1"/>
+          </a:fillRef>
+          <a:effectRef idx="2">
+            <a:schemeClr val="accent1"/>
+          </a:effectRef>
+          <a:fontRef idx="minor">
+            <a:schemeClr val="lt1"/>
+          </a:fontRef>
+        </p:style>
+        <p:txBody>
+          <a:bodyPr rtlCol="0" anchor="ctr"/>
+          <a:lstStyle/>
+          <a:p>
+            <a:pPr algn="ctr"/>
+          </a:p>
+        </p:txBody>
+      </p:sp>
+      <p:sp>
+        <p:nvSpPr>
+          <p:cNvPr id="5" name="TextBox 4"/>
+          <p:cNvSpPr txBox="1"/>
+          <p:nvPr/>
+        </p:nvSpPr>
+        <p:spPr>
+          <a:xfrm>
+            <a:off x="640080" y="960120"/>
+            <a:ext cx="10972800" cy="777240"/>
+          </a:xfrm>
+          <a:prstGeom prst="rect">
+            <a:avLst/>
+          </a:prstGeom>
+          <a:noFill/>
+        </p:spPr>
+        <p:txBody>
+          <a:bodyPr wrap="square" anchor="t" lIns="0" rIns="0" tIns="0" bIns="0">
+            <a:spAutoFit/>
+          </a:bodyPr>
+          <a:lstStyle/>
+          <a:p>
+            <a:pPr algn="l">
+              <a:lnSpc>
+                <a:spcPct val="106000"/>
+              </a:lnSpc>
+              <a:spcBef>
+                <a:spcPts val="0"/>
+              </a:spcBef>
+              <a:spcAft>
+                <a:spcPts val="500"/>
+              </a:spcAft>
+            </a:pPr>
+            <a:r>
+              <a:rPr sz="2100" b="1" i="0">
+                <a:solidFill>
+                  <a:srgbClr val="111111"/>
+                </a:solidFill>
+                <a:latin typeface="Microsoft JhengHei"/>
+              </a:rPr>
+              <a:t>這些只有你能回答</a:t>
+            </a:r>
+          </a:p>
+        </p:txBody>
+      </p:sp>
+      <p:sp>
+        <p:nvSpPr>
+          <p:cNvPr id="6" name="TextBox 5"/>
+          <p:cNvSpPr txBox="1"/>
+          <p:nvPr/>
+        </p:nvSpPr>
+        <p:spPr>
+          <a:xfrm>
+            <a:off x="640080" y="1783080"/>
+            <a:ext cx="10881360" cy="3291840"/>
+          </a:xfrm>
+          <a:prstGeom prst="rect">
+            <a:avLst/>
+          </a:prstGeom>
+          <a:noFill/>
+        </p:spPr>
+        <p:txBody>
+          <a:bodyPr wrap="square" anchor="t" lIns="0" rIns="0" tIns="0" bIns="0">
+            <a:spAutoFit/>
+          </a:bodyPr>
+          <a:lstStyle/>
+          <a:p>
+            <a:pPr algn="l">
+              <a:lnSpc>
+                <a:spcPct val="115000"/>
+              </a:lnSpc>
+              <a:spcBef>
+                <a:spcPts val="0"/>
+              </a:spcBef>
+              <a:spcAft>
+                <a:spcPts val="1000"/>
+              </a:spcAft>
+            </a:pPr>
+            <a:r>
+              <a:rPr sz="1500" b="0" i="0">
+                <a:solidFill>
+                  <a:srgbClr val="555B63"/>
+                </a:solidFill>
+                <a:latin typeface="Segoe UI"/>
+              </a:rPr>
+              <a:t>— </a:t>
+            </a:r>
+            <a:r>
+              <a:rPr sz="1500" b="1" i="0">
+                <a:solidFill>
+                  <a:srgbClr val="111111"/>
+                </a:solidFill>
+                <a:latin typeface="Microsoft JhengHei"/>
+              </a:rPr>
+              <a:t>1. 根因你賭哪邊:4D 差是「看得到沒用上」還是「根本沒看到」?你的證據?(meeting 必問)</a:t>
+            </a:r>
+          </a:p>
+          <a:p>
+            <a:pPr algn="l">
+              <a:lnSpc>
+                <a:spcPct val="115000"/>
+              </a:lnSpc>
+              <a:spcBef>
+                <a:spcPts val="0"/>
+              </a:spcBef>
+              <a:spcAft>
+                <a:spcPts val="1000"/>
+              </a:spcAft>
+            </a:pPr>
+            <a:r>
+              <a:rPr sz="1500" b="0" i="0">
+                <a:solidFill>
+                  <a:srgbClr val="555B63"/>
+                </a:solidFill>
+                <a:latin typeface="Segoe UI"/>
+              </a:rPr>
+              <a:t>— </a:t>
+            </a:r>
+            <a:r>
+              <a:rPr sz="1500" b="0" i="0">
+                <a:solidFill>
+                  <a:srgbClr val="111111"/>
+                </a:solidFill>
+                <a:latin typeface="Microsoft JhengHei"/>
+              </a:rPr>
+              <a:t>2. 偽標錯誤=reward 錯誤(蒸餾天花板):過濾低信心區域?混 GT?你的設計決策。</a:t>
+            </a:r>
+          </a:p>
+          <a:p>
+            <a:pPr algn="l">
+              <a:lnSpc>
+                <a:spcPct val="115000"/>
+              </a:lnSpc>
+              <a:spcBef>
+                <a:spcPts val="0"/>
+              </a:spcBef>
+              <a:spcAft>
+                <a:spcPts val="1000"/>
+              </a:spcAft>
+            </a:pPr>
+            <a:r>
+              <a:rPr sz="1500" b="0" i="0">
+                <a:solidFill>
+                  <a:srgbClr val="555B63"/>
+                </a:solidFill>
+                <a:latin typeface="Segoe UI"/>
+              </a:rPr>
+              <a:t>— </a:t>
+            </a:r>
+            <a:r>
+              <a:rPr sz="1500" b="0" i="0">
+                <a:solidFill>
+                  <a:srgbClr val="111111"/>
+                </a:solidFill>
+                <a:latin typeface="Microsoft JhengHei"/>
+              </a:rPr>
+              <a:t>3. flow-consistency reward 怎麼被 hack?想一個具體情境,再想怎麼防。</a:t>
+            </a:r>
+          </a:p>
+          <a:p>
+            <a:pPr algn="l">
+              <a:lnSpc>
+                <a:spcPct val="115000"/>
+              </a:lnSpc>
+              <a:spcBef>
+                <a:spcPts val="0"/>
+              </a:spcBef>
+              <a:spcAft>
+                <a:spcPts val="1000"/>
+              </a:spcAft>
+            </a:pPr>
+            <a:r>
+              <a:rPr sz="1500" b="0" i="0">
+                <a:solidFill>
+                  <a:srgbClr val="555B63"/>
+                </a:solidFill>
+                <a:latin typeface="Segoe UI"/>
+              </a:rPr>
+              <a:t>— </a:t>
+            </a:r>
+            <a:r>
+              <a:rPr sz="1500" b="0" i="0">
+                <a:solidFill>
+                  <a:srgbClr val="111111"/>
+                </a:solidFill>
+                <a:latin typeface="Microsoft JhengHei"/>
+              </a:rPr>
+              <a:t>4. 第一版訊號:2D flow(成熟)還是 scene flow(貼 4D)?跟你的時程綁定。</a:t>
+            </a:r>
+          </a:p>
+          <a:p>
+            <a:pPr algn="l">
+              <a:lnSpc>
+                <a:spcPct val="115000"/>
+              </a:lnSpc>
+              <a:spcBef>
+                <a:spcPts val="0"/>
+              </a:spcBef>
+              <a:spcAft>
+                <a:spcPts val="1000"/>
+              </a:spcAft>
+            </a:pPr>
+            <a:r>
+              <a:rPr sz="1500" b="0" i="0">
+                <a:solidFill>
+                  <a:srgbClr val="555B63"/>
+                </a:solidFill>
+                <a:latin typeface="Segoe UI"/>
+              </a:rPr>
+              <a:t>— </a:t>
+            </a:r>
+            <a:r>
+              <a:rPr sz="1500" b="0" i="0">
+                <a:solidFill>
+                  <a:srgbClr val="111111"/>
+                </a:solidFill>
+                <a:latin typeface="Microsoft JhengHei"/>
+              </a:rPr>
+              <a:t>5. 讀完 4D-RGPT(在你的 papers/ 裡)後:它跟我們的差異,一句話講出來。</a:t>
+            </a:r>
+          </a:p>
+          <a:p>
+            <a:pPr algn="l">
+              <a:lnSpc>
+                <a:spcPct val="115000"/>
+              </a:lnSpc>
+              <a:spcBef>
+                <a:spcPts val="0"/>
+              </a:spcBef>
+              <a:spcAft>
+                <a:spcPts val="1000"/>
+              </a:spcAft>
+            </a:pPr>
+            <a:r>
+              <a:rPr sz="1500" b="0" i="0">
+                <a:solidFill>
+                  <a:srgbClr val="555B63"/>
+                </a:solidFill>
+                <a:latin typeface="Segoe UI"/>
+              </a:rPr>
+              <a:t>— </a:t>
+            </a:r>
+            <a:r>
+              <a:rPr sz="1500" b="1" i="0">
+                <a:solidFill>
+                  <a:srgbClr val="111111"/>
+                </a:solidFill>
+                <a:latin typeface="Microsoft JhengHei"/>
+              </a:rPr>
+              <a:t>6. 一句話賣點,自己重寫(P7 的只是靶子)。</a:t>
+            </a:r>
+          </a:p>
+        </p:txBody>
+      </p:sp>
+      <p:sp>
+        <p:nvSpPr>
+          <p:cNvPr id="7" name="TextBox 6"/>
+          <p:cNvSpPr txBox="1"/>
+          <p:nvPr/>
+        </p:nvSpPr>
+        <p:spPr>
+          <a:xfrm>
+            <a:off x="640080" y="5806440"/>
+            <a:ext cx="10881360" cy="548640"/>
+          </a:xfrm>
+          <a:prstGeom prst="rect">
+            <a:avLst/>
+          </a:prstGeom>
+          <a:noFill/>
+        </p:spPr>
+        <p:txBody>
+          <a:bodyPr wrap="square" anchor="t" lIns="0" rIns="0" tIns="0" bIns="0">
+            <a:spAutoFit/>
+          </a:bodyPr>
+          <a:lstStyle/>
+          <a:p>
+            <a:pPr algn="l">
+              <a:lnSpc>
+                <a:spcPct val="110000"/>
+              </a:lnSpc>
+              <a:spcBef>
+                <a:spcPts val="0"/>
+              </a:spcBef>
+              <a:spcAft>
+                <a:spcPts val="500"/>
+              </a:spcAft>
+            </a:pPr>
+            <a:r>
+              <a:rPr sz="1200" b="1" i="0">
+                <a:solidFill>
+                  <a:srgbClr val="B44A1E"/>
+                </a:solidFill>
+                <a:latin typeface="Microsoft JhengHei"/>
+              </a:rPr>
+              <a:t>聲明:本簡報為分析草稿。任何要放進正式簡報/報告的文字,須由報告者自己重寫——重寫即消化。</a:t>
+            </a:r>
+          </a:p>
+        </p:txBody>
+      </p:sp>
+      <p:sp>
+        <p:nvSpPr>
+          <p:cNvPr id="8" name="TextBox 7"/>
+          <p:cNvSpPr txBox="1"/>
+          <p:nvPr/>
+        </p:nvSpPr>
+        <p:spPr>
+          <a:xfrm>
+            <a:off x="10881360" y="6510528"/>
+            <a:ext cx="1097280" cy="274320"/>
+          </a:xfrm>
+          <a:prstGeom prst="rect">
+            <a:avLst/>
+          </a:prstGeom>
+          <a:noFill/>
+        </p:spPr>
+        <p:txBody>
+          <a:bodyPr wrap="square" anchor="t" lIns="0" rIns="0" tIns="0" bIns="0">
+            <a:spAutoFit/>
+          </a:bodyPr>
+          <a:lstStyle/>
+          <a:p>
+            <a:pPr algn="r">
+              <a:lnSpc>
+                <a:spcPct val="110000"/>
+              </a:lnSpc>
+              <a:spcBef>
+                <a:spcPts val="0"/>
+              </a:spcBef>
+              <a:spcAft>
+                <a:spcPts val="500"/>
+              </a:spcAft>
+            </a:pPr>
+            <a:r>
+              <a:rPr sz="900" b="0" i="0">
+                <a:solidFill>
+                  <a:srgbClr val="555B63"/>
+                </a:solidFill>
+                <a:latin typeface="Segoe UI"/>
+              </a:rPr>
+              <a:t>10/10 · 草稿</a:t>
             </a:r>
           </a:p>
         </p:txBody>
@@ -5170,7 +5745,7 @@
                 </a:solidFill>
                 <a:latin typeface="Segoe UI"/>
               </a:rPr>
-              <a:t>2/9 · 草稿</a:t>
+              <a:t>2/10 · 草稿</a:t>
             </a:r>
           </a:p>
         </p:txBody>
@@ -5744,7 +6319,7 @@
                 </a:solidFill>
                 <a:latin typeface="Segoe UI"/>
               </a:rPr>
-              <a:t>3/9 · 草稿</a:t>
+              <a:t>3/10 · 草稿</a:t>
             </a:r>
           </a:p>
         </p:txBody>
@@ -6249,7 +6824,7 @@
                 </a:solidFill>
                 <a:latin typeface="Segoe UI"/>
               </a:rPr>
-              <a:t>4/9 · 草稿</a:t>
+              <a:t>4/10 · 草稿</a:t>
             </a:r>
           </a:p>
         </p:txBody>
@@ -6723,7 +7298,7 @@
                 </a:solidFill>
                 <a:latin typeface="Segoe UI"/>
               </a:rPr>
-              <a:t>5/9 · 草稿</a:t>
+              <a:t>5/10 · 草稿</a:t>
             </a:r>
           </a:p>
         </p:txBody>
@@ -7266,7 +7841,7 @@
                 </a:solidFill>
                 <a:latin typeface="Segoe UI"/>
               </a:rPr>
-              <a:t>6/9 · 草稿</a:t>
+              <a:t>6/10 · 草稿</a:t>
             </a:r>
           </a:p>
         </p:txBody>
@@ -7809,7 +8384,7 @@
                 </a:solidFill>
                 <a:latin typeface="Segoe UI"/>
               </a:rPr>
-              <a:t>7/9 · 草稿</a:t>
+              <a:t>7/10 · 草稿</a:t>
             </a:r>
           </a:p>
         </p:txBody>
@@ -8738,7 +9313,7 @@
                 </a:solidFill>
                 <a:latin typeface="Segoe UI"/>
               </a:rPr>
-              <a:t>8/9 · 草稿</a:t>
+              <a:t>8/10 · 草稿</a:t>
             </a:r>
           </a:p>
         </p:txBody>
@@ -8845,7 +9420,7 @@
                 </a:solidFill>
                 <a:latin typeface="Segoe UI"/>
               </a:rPr>
-              <a:t>Q9　</a:t>
+              <a:t>Q8b　</a:t>
             </a:r>
             <a:r>
               <a:rPr sz="1250" b="0" i="0">
@@ -8854,7 +9429,7 @@
                 </a:solidFill>
                 <a:latin typeface="Microsoft JhengHei"/>
               </a:rPr>
-              <a:t>skill 憲法第 4 條:這些問題 Claude 回答不了,由你回答。</a:t>
+              <a:t>補充:這些 benchmark 的題目長什麼樣?(題型 + 範例)</a:t>
             </a:r>
           </a:p>
         </p:txBody>
@@ -8937,13 +9512,13 @@
               </a:spcAft>
             </a:pPr>
             <a:r>
-              <a:rPr sz="2100" b="1" i="0">
+              <a:rPr sz="2000" b="1" i="0">
                 <a:solidFill>
                   <a:srgbClr val="111111"/>
                 </a:solidFill>
                 <a:latin typeface="Microsoft JhengHei"/>
               </a:rPr>
-              <a:t>這些只有你能回答</a:t>
+              <a:t>兩種答案格式:選擇題(MCA)與數值題(NA,相對準確率計分)</a:t>
             </a:r>
           </a:p>
         </p:txBody>
@@ -8957,7 +9532,7 @@
         <p:spPr>
           <a:xfrm>
             <a:off x="640080" y="1783080"/>
-            <a:ext cx="10881360" cy="3291840"/>
+            <a:ext cx="6126480" cy="3291840"/>
           </a:xfrm>
           <a:prstGeom prst="rect">
             <a:avLst/>
@@ -8978,11 +9553,11 @@
                 <a:spcPts val="0"/>
               </a:spcBef>
               <a:spcAft>
-                <a:spcPts val="1000"/>
+                <a:spcPts val="800"/>
               </a:spcAft>
             </a:pPr>
             <a:r>
-              <a:rPr sz="1500" b="0" i="0">
+              <a:rPr sz="1250" b="0" i="0">
                 <a:solidFill>
                   <a:srgbClr val="555B63"/>
                 </a:solidFill>
@@ -8991,13 +9566,22 @@
               <a:t>— </a:t>
             </a:r>
             <a:r>
-              <a:rPr sz="1500" b="1" i="0">
+              <a:rPr sz="1250" b="1" i="0">
                 <a:solidFill>
                   <a:srgbClr val="111111"/>
                 </a:solidFill>
                 <a:latin typeface="Microsoft JhengHei"/>
               </a:rPr>
-              <a:t>1. 根因你賭哪邊:4D 差是「看得到沒用上」還是「根本沒看到」?你的證據?(meeting 必問)</a:t>
+              <a:t>VLM4D — 選擇題:</a:t>
+            </a:r>
+            <a:r>
+              <a:rPr sz="1250" b="0" i="0">
+                <a:solidFill>
+                  <a:srgbClr val="111111"/>
+                </a:solidFill>
+                <a:latin typeface="Microsoft JhengHei"/>
+              </a:rPr>
+              <a:t>「From the camera's perspective, which direction is the car moving?  (A) left  (B) right  (C) toward  (D) away」→ 正解 (B);右圖為論文 teaser:人類秒答 right,模型答 left。</a:t>
             </a:r>
           </a:p>
           <a:p>
@@ -9009,11 +9593,11 @@
                 <a:spcPts val="0"/>
               </a:spcBef>
               <a:spcAft>
-                <a:spcPts val="1000"/>
+                <a:spcPts val="800"/>
               </a:spcAft>
             </a:pPr>
             <a:r>
-              <a:rPr sz="1500" b="0" i="0">
+              <a:rPr sz="1250" b="0" i="0">
                 <a:solidFill>
                   <a:srgbClr val="555B63"/>
                 </a:solidFill>
@@ -9022,13 +9606,22 @@
               <a:t>— </a:t>
             </a:r>
             <a:r>
-              <a:rPr sz="1500" b="0" i="0">
+              <a:rPr sz="1250" b="1" i="0">
                 <a:solidFill>
                   <a:srgbClr val="111111"/>
                 </a:solidFill>
                 <a:latin typeface="Microsoft JhengHei"/>
               </a:rPr>
-              <a:t>2. 偽標錯誤=reward 錯誤(蒸餾天花板):過濾低信心區域?混 GT?你的設計決策。</a:t>
+              <a:t>VSI-Bench — 兩型:</a:t>
+            </a:r>
+            <a:r>
+              <a:rPr sz="1250" b="0" i="0">
+                <a:solidFill>
+                  <a:srgbClr val="111111"/>
+                </a:solidFill>
+                <a:latin typeface="Microsoft JhengHei"/>
+              </a:rPr>
+              <a:t>MCA 選擇題(相對方向/路線規劃/出現順序)+ NA 數值題(「How many chairs?」「兩物距離幾公尺?」)— 數值題以相對準確率(MRA)計分,不是全對全錯。</a:t>
             </a:r>
           </a:p>
           <a:p>
@@ -9040,11 +9633,11 @@
                 <a:spcPts val="0"/>
               </a:spcBef>
               <a:spcAft>
-                <a:spcPts val="1000"/>
+                <a:spcPts val="800"/>
               </a:spcAft>
             </a:pPr>
             <a:r>
-              <a:rPr sz="1500" b="0" i="0">
+              <a:rPr sz="1250" b="0" i="0">
                 <a:solidFill>
                   <a:srgbClr val="555B63"/>
                 </a:solidFill>
@@ -9053,13 +9646,22 @@
               <a:t>— </a:t>
             </a:r>
             <a:r>
-              <a:rPr sz="1500" b="0" i="0">
+              <a:rPr sz="1250" b="1" i="0">
                 <a:solidFill>
                   <a:srgbClr val="111111"/>
                 </a:solidFill>
                 <a:latin typeface="Microsoft JhengHei"/>
               </a:rPr>
-              <a:t>3. flow-consistency reward 怎麼被 hack?想一個具體情境,再想怎麼防。</a:t>
+              <a:t>STI-Bench — 定量選擇題:</a:t>
+            </a:r>
+            <a:r>
+              <a:rPr sz="1250" b="0" i="0">
+                <a:solidFill>
+                  <a:srgbClr val="111111"/>
+                </a:solidFill>
+                <a:latin typeface="Microsoft JhengHei"/>
+              </a:rPr>
+              <a:t>「物體位移多少公尺 / 速度多少 m/s / 尺寸多大」,選項為數值區間 → 逼模型做度量級估計,不能靠語意矇。</a:t>
             </a:r>
           </a:p>
           <a:p>
@@ -9071,11 +9673,11 @@
                 <a:spcPts val="0"/>
               </a:spcBef>
               <a:spcAft>
-                <a:spcPts val="1000"/>
+                <a:spcPts val="800"/>
               </a:spcAft>
             </a:pPr>
             <a:r>
-              <a:rPr sz="1500" b="0" i="0">
+              <a:rPr sz="1250" b="0" i="0">
                 <a:solidFill>
                   <a:srgbClr val="555B63"/>
                 </a:solidFill>
@@ -9084,89 +9686,105 @@
               <a:t>— </a:t>
             </a:r>
             <a:r>
-              <a:rPr sz="1500" b="0" i="0">
+              <a:rPr sz="1250" b="1" i="0">
                 <a:solidFill>
                   <a:srgbClr val="111111"/>
                 </a:solidFill>
                 <a:latin typeface="Microsoft JhengHei"/>
               </a:rPr>
-              <a:t>4. 第一版訊號:2D flow(成熟)還是 scene flow(貼 4D)?跟你的時程綁定。</a:t>
-            </a:r>
-          </a:p>
-          <a:p>
-            <a:pPr algn="l">
+              <a:t>R4D/VSTI — 混合:</a:t>
+            </a:r>
+            <a:r>
+              <a:rPr sz="1250" b="0" i="0">
+                <a:solidFill>
+                  <a:srgbClr val="111111"/>
+                </a:solidFill>
+                <a:latin typeface="Microsoft JhengHei"/>
+              </a:rPr>
+              <a:t>多選 + 數值題(相對準確率);R4D 另加 region 提示(框住問的物體)。</a:t>
+            </a:r>
+          </a:p>
+        </p:txBody>
+      </p:sp>
+      <p:pic>
+        <p:nvPicPr>
+          <p:cNvPr id="7" name="Picture 6" descr="VLM4D_x1.png"/>
+          <p:cNvPicPr>
+            <a:picLocks noChangeAspect="1"/>
+          </p:cNvPicPr>
+          <p:nvPr/>
+        </p:nvPicPr>
+        <p:blipFill>
+          <a:blip r:embed="rId2"/>
+          <a:stretch>
+            <a:fillRect/>
+          </a:stretch>
+        </p:blipFill>
+        <p:spPr>
+          <a:xfrm>
+            <a:off x="7040880" y="2455668"/>
+            <a:ext cx="4480560" cy="2495303"/>
+          </a:xfrm>
+          <a:prstGeom prst="rect">
+            <a:avLst/>
+          </a:prstGeom>
+        </p:spPr>
+      </p:pic>
+      <p:sp>
+        <p:nvSpPr>
+          <p:cNvPr id="8" name="TextBox 7"/>
+          <p:cNvSpPr txBox="1"/>
+          <p:nvPr/>
+        </p:nvSpPr>
+        <p:spPr>
+          <a:xfrm>
+            <a:off x="7040880" y="4978403"/>
+            <a:ext cx="4480560" cy="274320"/>
+          </a:xfrm>
+          <a:prstGeom prst="rect">
+            <a:avLst/>
+          </a:prstGeom>
+          <a:noFill/>
+        </p:spPr>
+        <p:txBody>
+          <a:bodyPr wrap="square" anchor="t" lIns="0" rIns="0" tIns="0" bIns="0">
+            <a:spAutoFit/>
+          </a:bodyPr>
+          <a:lstStyle/>
+          <a:p>
+            <a:pPr algn="ctr">
               <a:lnSpc>
-                <a:spcPct val="115000"/>
+                <a:spcPct val="110000"/>
               </a:lnSpc>
               <a:spcBef>
                 <a:spcPts val="0"/>
               </a:spcBef>
               <a:spcAft>
-                <a:spcPts val="1000"/>
+                <a:spcPts val="500"/>
               </a:spcAft>
             </a:pPr>
             <a:r>
-              <a:rPr sz="1500" b="0" i="0">
+              <a:rPr sz="950" b="0" i="1">
                 <a:solidFill>
                   <a:srgbClr val="555B63"/>
                 </a:solidFill>
-                <a:latin typeface="Segoe UI"/>
-              </a:rPr>
-              <a:t>— </a:t>
-            </a:r>
-            <a:r>
-              <a:rPr sz="1500" b="0" i="0">
-                <a:solidFill>
-                  <a:srgbClr val="111111"/>
-                </a:solidFill>
                 <a:latin typeface="Microsoft JhengHei"/>
               </a:rPr>
-              <a:t>5. 讀完 4D-RGPT(在你的 papers/ 裡)後:它跟我們的差異,一句話講出來。</a:t>
-            </a:r>
-          </a:p>
-          <a:p>
-            <a:pPr algn="l">
-              <a:lnSpc>
-                <a:spcPct val="115000"/>
-              </a:lnSpc>
-              <a:spcBef>
-                <a:spcPts val="0"/>
-              </a:spcBef>
-              <a:spcAft>
-                <a:spcPts val="1000"/>
-              </a:spcAft>
-            </a:pPr>
-            <a:r>
-              <a:rPr sz="1500" b="0" i="0">
-                <a:solidFill>
-                  <a:srgbClr val="555B63"/>
-                </a:solidFill>
-                <a:latin typeface="Segoe UI"/>
-              </a:rPr>
-              <a:t>— </a:t>
-            </a:r>
-            <a:r>
-              <a:rPr sz="1500" b="1" i="0">
-                <a:solidFill>
-                  <a:srgbClr val="111111"/>
-                </a:solidFill>
-                <a:latin typeface="Microsoft JhengHei"/>
-              </a:rPr>
-              <a:t>6. 一句話賣點,自己重寫(P7 的只是靶子)。</a:t>
-            </a:r>
-          </a:p>
-        </p:txBody>
-      </p:sp>
-      <p:sp>
-        <p:nvSpPr>
-          <p:cNvPr id="7" name="TextBox 6"/>
+              <a:t>VLM4D teaser:車往右移,模型答「left」(取自 arXiv 2508.02095 原圖)</a:t>
+            </a:r>
+          </a:p>
+        </p:txBody>
+      </p:sp>
+      <p:sp>
+        <p:nvSpPr>
+          <p:cNvPr id="9" name="TextBox 8"/>
           <p:cNvSpPr txBox="1"/>
           <p:nvPr/>
         </p:nvSpPr>
         <p:spPr>
           <a:xfrm>
             <a:off x="640080" y="5806440"/>
-            <a:ext cx="10881360" cy="548640"/>
+            <a:ext cx="10881360" cy="594360"/>
           </a:xfrm>
           <a:prstGeom prst="rect">
             <a:avLst/>
@@ -9191,20 +9809,83 @@
               </a:spcAft>
             </a:pPr>
             <a:r>
-              <a:rPr sz="1200" b="1" i="0">
+              <a:rPr sz="1150" b="1" i="0">
                 <a:solidFill>
                   <a:srgbClr val="B44A1E"/>
                 </a:solidFill>
                 <a:latin typeface="Microsoft JhengHei"/>
               </a:rPr>
-              <a:t>聲明:本簡報為分析草稿。任何要放進正式簡報/報告的文字,須由報告者自己重寫——重寫即消化。</a:t>
-            </a:r>
-          </a:p>
-        </p:txBody>
-      </p:sp>
-      <p:sp>
-        <p:nvSpPr>
-          <p:cNvPr id="8" name="TextBox 7"/>
+              <a:t>未驗證：</a:t>
+            </a:r>
+            <a:r>
+              <a:rPr sz="1150" b="0" i="0">
+                <a:solidFill>
+                  <a:srgbClr val="111111"/>
+                </a:solidFill>
+                <a:latin typeface="Microsoft JhengHei"/>
+              </a:rPr>
+              <a:t>除 VLM4D 圖為原文外,其餘題目文字為依各論文題型描述改寫的示意,非原題;報告前建議各抓 1 題原題替換(VSI/STI 官網或論文附錄)。</a:t>
+            </a:r>
+          </a:p>
+        </p:txBody>
+      </p:sp>
+      <p:sp>
+        <p:nvSpPr>
+          <p:cNvPr id="10" name="TextBox 9"/>
+          <p:cNvSpPr txBox="1"/>
+          <p:nvPr/>
+        </p:nvSpPr>
+        <p:spPr>
+          <a:xfrm>
+            <a:off x="640080" y="6355080"/>
+            <a:ext cx="10058400" cy="320040"/>
+          </a:xfrm>
+          <a:prstGeom prst="rect">
+            <a:avLst/>
+          </a:prstGeom>
+          <a:noFill/>
+        </p:spPr>
+        <p:txBody>
+          <a:bodyPr wrap="square" anchor="t" lIns="0" rIns="0" tIns="0" bIns="0">
+            <a:spAutoFit/>
+          </a:bodyPr>
+          <a:lstStyle/>
+          <a:p>
+            <a:pPr algn="l">
+              <a:lnSpc>
+                <a:spcPct val="110000"/>
+              </a:lnSpc>
+              <a:spcBef>
+                <a:spcPts val="0"/>
+              </a:spcBef>
+              <a:spcAft>
+                <a:spcPts val="500"/>
+              </a:spcAft>
+            </a:pPr>
+            <a:r>
+              <a:rPr sz="950" b="1" i="0">
+                <a:solidFill>
+                  <a:srgbClr val="555B63"/>
+                </a:solidFill>
+                <a:latin typeface="Microsoft JhengHei"/>
+              </a:rPr>
+              <a:t>依據：</a:t>
+            </a:r>
+            <a:r>
+              <a:rPr sz="950" b="0" i="1">
+                <a:solidFill>
+                  <a:srgbClr val="555B63"/>
+                </a:solidFill>
+                <a:latin typeface="Segoe UI"/>
+              </a:rPr>
+              <a:t>VLM4D 2508.02095(MCQ)· VSI-Bench(MCA+NA/MRA)· STI-Bench(定量 MCQ)· 4D-RGPT(R4D 多選+數值)</a:t>
+            </a:r>
+          </a:p>
+        </p:txBody>
+      </p:sp>
+      <p:sp>
+        <p:nvSpPr>
+          <p:cNvPr id="11" name="TextBox 10"/>
           <p:cNvSpPr txBox="1"/>
           <p:nvPr/>
         </p:nvSpPr>
@@ -9242,7 +9923,7 @@
                 </a:solidFill>
                 <a:latin typeface="Segoe UI"/>
               </a:rPr>
-              <a:t>9/9 · 草稿</a:t>
+              <a:t>9/10 · 草稿</a:t>
             </a:r>
           </a:p>
         </p:txBody>

</xml_diff>